<commit_message>
Figures updated for final version in Fig. 3. Need to revise Fig. 2 used parameters and charge distribution. Also some location and alignments are needed to be revised.
</commit_message>
<xml_diff>
--- a/figures/Figures-EDL202603-manuscript.pptx
+++ b/figures/Figures-EDL202603-manuscript.pptx
@@ -208,7 +208,7 @@
           <a:p>
             <a:fld id="{AA311422-0C2E-42D7-924E-F365B5A34ABC}" type="datetimeFigureOut">
               <a:rPr lang="ko-KR" altLang="en-US" smtClean="0"/>
-              <a:t>2026-03-18</a:t>
+              <a:t>2026-03-30</a:t>
             </a:fld>
             <a:endParaRPr lang="ko-KR" altLang="en-US"/>
           </a:p>
@@ -606,7 +606,7 @@
           <a:p>
             <a:fld id="{038C53AF-CD6D-418E-B451-BA3CFECC6915}" type="datetimeFigureOut">
               <a:rPr lang="ko-KR" altLang="en-US" smtClean="0"/>
-              <a:t>2026-03-18</a:t>
+              <a:t>2026-03-30</a:t>
             </a:fld>
             <a:endParaRPr lang="ko-KR" altLang="en-US"/>
           </a:p>
@@ -776,7 +776,7 @@
           <a:p>
             <a:fld id="{038C53AF-CD6D-418E-B451-BA3CFECC6915}" type="datetimeFigureOut">
               <a:rPr lang="ko-KR" altLang="en-US" smtClean="0"/>
-              <a:t>2026-03-18</a:t>
+              <a:t>2026-03-30</a:t>
             </a:fld>
             <a:endParaRPr lang="ko-KR" altLang="en-US"/>
           </a:p>
@@ -956,7 +956,7 @@
           <a:p>
             <a:fld id="{038C53AF-CD6D-418E-B451-BA3CFECC6915}" type="datetimeFigureOut">
               <a:rPr lang="ko-KR" altLang="en-US" smtClean="0"/>
-              <a:t>2026-03-18</a:t>
+              <a:t>2026-03-30</a:t>
             </a:fld>
             <a:endParaRPr lang="ko-KR" altLang="en-US"/>
           </a:p>
@@ -1126,7 +1126,7 @@
           <a:p>
             <a:fld id="{038C53AF-CD6D-418E-B451-BA3CFECC6915}" type="datetimeFigureOut">
               <a:rPr lang="ko-KR" altLang="en-US" smtClean="0"/>
-              <a:t>2026-03-18</a:t>
+              <a:t>2026-03-30</a:t>
             </a:fld>
             <a:endParaRPr lang="ko-KR" altLang="en-US"/>
           </a:p>
@@ -1372,7 +1372,7 @@
           <a:p>
             <a:fld id="{038C53AF-CD6D-418E-B451-BA3CFECC6915}" type="datetimeFigureOut">
               <a:rPr lang="ko-KR" altLang="en-US" smtClean="0"/>
-              <a:t>2026-03-18</a:t>
+              <a:t>2026-03-30</a:t>
             </a:fld>
             <a:endParaRPr lang="ko-KR" altLang="en-US"/>
           </a:p>
@@ -1604,7 +1604,7 @@
           <a:p>
             <a:fld id="{038C53AF-CD6D-418E-B451-BA3CFECC6915}" type="datetimeFigureOut">
               <a:rPr lang="ko-KR" altLang="en-US" smtClean="0"/>
-              <a:t>2026-03-18</a:t>
+              <a:t>2026-03-30</a:t>
             </a:fld>
             <a:endParaRPr lang="ko-KR" altLang="en-US"/>
           </a:p>
@@ -1971,7 +1971,7 @@
           <a:p>
             <a:fld id="{038C53AF-CD6D-418E-B451-BA3CFECC6915}" type="datetimeFigureOut">
               <a:rPr lang="ko-KR" altLang="en-US" smtClean="0"/>
-              <a:t>2026-03-18</a:t>
+              <a:t>2026-03-30</a:t>
             </a:fld>
             <a:endParaRPr lang="ko-KR" altLang="en-US"/>
           </a:p>
@@ -2089,7 +2089,7 @@
           <a:p>
             <a:fld id="{038C53AF-CD6D-418E-B451-BA3CFECC6915}" type="datetimeFigureOut">
               <a:rPr lang="ko-KR" altLang="en-US" smtClean="0"/>
-              <a:t>2026-03-18</a:t>
+              <a:t>2026-03-30</a:t>
             </a:fld>
             <a:endParaRPr lang="ko-KR" altLang="en-US"/>
           </a:p>
@@ -2184,7 +2184,7 @@
           <a:p>
             <a:fld id="{038C53AF-CD6D-418E-B451-BA3CFECC6915}" type="datetimeFigureOut">
               <a:rPr lang="ko-KR" altLang="en-US" smtClean="0"/>
-              <a:t>2026-03-18</a:t>
+              <a:t>2026-03-30</a:t>
             </a:fld>
             <a:endParaRPr lang="ko-KR" altLang="en-US"/>
           </a:p>
@@ -2461,7 +2461,7 @@
           <a:p>
             <a:fld id="{038C53AF-CD6D-418E-B451-BA3CFECC6915}" type="datetimeFigureOut">
               <a:rPr lang="ko-KR" altLang="en-US" smtClean="0"/>
-              <a:t>2026-03-18</a:t>
+              <a:t>2026-03-30</a:t>
             </a:fld>
             <a:endParaRPr lang="ko-KR" altLang="en-US"/>
           </a:p>
@@ -2718,7 +2718,7 @@
           <a:p>
             <a:fld id="{038C53AF-CD6D-418E-B451-BA3CFECC6915}" type="datetimeFigureOut">
               <a:rPr lang="ko-KR" altLang="en-US" smtClean="0"/>
-              <a:t>2026-03-18</a:t>
+              <a:t>2026-03-30</a:t>
             </a:fld>
             <a:endParaRPr lang="ko-KR" altLang="en-US"/>
           </a:p>
@@ -2931,7 +2931,7 @@
           <a:p>
             <a:fld id="{038C53AF-CD6D-418E-B451-BA3CFECC6915}" type="datetimeFigureOut">
               <a:rPr lang="ko-KR" altLang="en-US" smtClean="0"/>
-              <a:t>2026-03-18</a:t>
+              <a:t>2026-03-30</a:t>
             </a:fld>
             <a:endParaRPr lang="ko-KR" altLang="en-US"/>
           </a:p>
@@ -9984,8 +9984,8 @@
             </a:fontRef>
           </p:style>
         </p:cxnSp>
-        <mc:AlternateContent xmlns:mc="http://schemas.openxmlformats.org/markup-compatibility/2006">
-          <mc:Choice xmlns:a14="http://schemas.microsoft.com/office/drawing/2010/main" Requires="a14">
+        <mc:AlternateContent xmlns:mc="http://schemas.openxmlformats.org/markup-compatibility/2006" xmlns:a14="http://schemas.microsoft.com/office/drawing/2010/main">
+          <mc:Choice Requires="a14">
             <p:sp>
               <p:nvSpPr>
                 <p:cNvPr id="269" name="TextBox 268">
@@ -10054,7 +10054,7 @@
               </p:txBody>
             </p:sp>
           </mc:Choice>
-          <mc:Fallback>
+          <mc:Fallback xmlns="">
             <p:sp>
               <p:nvSpPr>
                 <p:cNvPr id="269" name="TextBox 268">
@@ -10099,8 +10099,8 @@
             </p:sp>
           </mc:Fallback>
         </mc:AlternateContent>
-        <mc:AlternateContent xmlns:mc="http://schemas.openxmlformats.org/markup-compatibility/2006">
-          <mc:Choice xmlns:a14="http://schemas.microsoft.com/office/drawing/2010/main" Requires="a14">
+        <mc:AlternateContent xmlns:mc="http://schemas.openxmlformats.org/markup-compatibility/2006" xmlns:a14="http://schemas.microsoft.com/office/drawing/2010/main">
+          <mc:Choice Requires="a14">
             <p:sp>
               <p:nvSpPr>
                 <p:cNvPr id="270" name="TextBox 269">
@@ -10169,7 +10169,7 @@
               </p:txBody>
             </p:sp>
           </mc:Choice>
-          <mc:Fallback>
+          <mc:Fallback xmlns="">
             <p:sp>
               <p:nvSpPr>
                 <p:cNvPr id="270" name="TextBox 269">
@@ -10214,8 +10214,8 @@
             </p:sp>
           </mc:Fallback>
         </mc:AlternateContent>
-        <mc:AlternateContent xmlns:mc="http://schemas.openxmlformats.org/markup-compatibility/2006">
-          <mc:Choice xmlns:a14="http://schemas.microsoft.com/office/drawing/2010/main" Requires="a14">
+        <mc:AlternateContent xmlns:mc="http://schemas.openxmlformats.org/markup-compatibility/2006" xmlns:a14="http://schemas.microsoft.com/office/drawing/2010/main">
+          <mc:Choice Requires="a14">
             <p:sp>
               <p:nvSpPr>
                 <p:cNvPr id="271" name="TextBox 270">
@@ -10284,7 +10284,7 @@
               </p:txBody>
             </p:sp>
           </mc:Choice>
-          <mc:Fallback>
+          <mc:Fallback xmlns="">
             <p:sp>
               <p:nvSpPr>
                 <p:cNvPr id="271" name="TextBox 270">
@@ -10329,8 +10329,8 @@
             </p:sp>
           </mc:Fallback>
         </mc:AlternateContent>
-        <mc:AlternateContent xmlns:mc="http://schemas.openxmlformats.org/markup-compatibility/2006">
-          <mc:Choice xmlns:a14="http://schemas.microsoft.com/office/drawing/2010/main" Requires="a14">
+        <mc:AlternateContent xmlns:mc="http://schemas.openxmlformats.org/markup-compatibility/2006" xmlns:a14="http://schemas.microsoft.com/office/drawing/2010/main">
+          <mc:Choice Requires="a14">
             <p:sp>
               <p:nvSpPr>
                 <p:cNvPr id="272" name="TextBox 271">
@@ -10399,7 +10399,7 @@
               </p:txBody>
             </p:sp>
           </mc:Choice>
-          <mc:Fallback>
+          <mc:Fallback xmlns="">
             <p:sp>
               <p:nvSpPr>
                 <p:cNvPr id="272" name="TextBox 271">
@@ -10444,8 +10444,8 @@
             </p:sp>
           </mc:Fallback>
         </mc:AlternateContent>
-        <mc:AlternateContent xmlns:mc="http://schemas.openxmlformats.org/markup-compatibility/2006">
-          <mc:Choice xmlns:a14="http://schemas.microsoft.com/office/drawing/2010/main" Requires="a14">
+        <mc:AlternateContent xmlns:mc="http://schemas.openxmlformats.org/markup-compatibility/2006" xmlns:a14="http://schemas.microsoft.com/office/drawing/2010/main">
+          <mc:Choice Requires="a14">
             <p:sp>
               <p:nvSpPr>
                 <p:cNvPr id="273" name="TextBox 272">
@@ -10514,7 +10514,7 @@
               </p:txBody>
             </p:sp>
           </mc:Choice>
-          <mc:Fallback>
+          <mc:Fallback xmlns="">
             <p:sp>
               <p:nvSpPr>
                 <p:cNvPr id="273" name="TextBox 272">
@@ -10559,8 +10559,8 @@
             </p:sp>
           </mc:Fallback>
         </mc:AlternateContent>
-        <mc:AlternateContent xmlns:mc="http://schemas.openxmlformats.org/markup-compatibility/2006">
-          <mc:Choice xmlns:a14="http://schemas.microsoft.com/office/drawing/2010/main" Requires="a14">
+        <mc:AlternateContent xmlns:mc="http://schemas.openxmlformats.org/markup-compatibility/2006" xmlns:a14="http://schemas.microsoft.com/office/drawing/2010/main">
+          <mc:Choice Requires="a14">
             <p:sp>
               <p:nvSpPr>
                 <p:cNvPr id="274" name="TextBox 273">
@@ -10629,7 +10629,7 @@
               </p:txBody>
             </p:sp>
           </mc:Choice>
-          <mc:Fallback>
+          <mc:Fallback xmlns="">
             <p:sp>
               <p:nvSpPr>
                 <p:cNvPr id="274" name="TextBox 273">
@@ -12325,8 +12325,8 @@
             <a:chExt cx="3094038" cy="1063612"/>
           </a:xfrm>
         </p:grpSpPr>
-        <mc:AlternateContent xmlns:mc="http://schemas.openxmlformats.org/markup-compatibility/2006">
-          <mc:Choice xmlns:a14="http://schemas.microsoft.com/office/drawing/2010/main" Requires="a14">
+        <mc:AlternateContent xmlns:mc="http://schemas.openxmlformats.org/markup-compatibility/2006" xmlns:a14="http://schemas.microsoft.com/office/drawing/2010/main">
+          <mc:Choice Requires="a14">
             <p:graphicFrame>
               <p:nvGraphicFramePr>
                 <p:cNvPr id="66" name="개체 65">
@@ -12397,7 +12397,7 @@
               </a:graphic>
             </p:graphicFrame>
           </mc:Choice>
-          <mc:Fallback>
+          <mc:Fallback xmlns="">
             <p:graphicFrame>
               <p:nvGraphicFramePr>
                 <p:cNvPr id="66" name="개체 65">
@@ -12426,12 +12426,12 @@
                 <a:graphicData uri="http://schemas.openxmlformats.org/presentationml/2006/ole">
                   <mc:AlternateContent>
                     <mc:Choice xmlns:v="urn:schemas-microsoft-com:vml" Requires="v">
-                      <p:oleObj name="Graph" r:id="rId7" imgW="6788458" imgH="2335684" progId="Origin50.Graph">
+                      <p:oleObj name="Graph" r:id="rId9" imgW="6788458" imgH="2335684" progId="Origin50.Graph">
                         <p:embed/>
                       </p:oleObj>
                     </mc:Choice>
                     <mc:Fallback>
-                      <p:oleObj name="Graph" r:id="rId7" imgW="6788458" imgH="2335684" progId="Origin50.Graph">
+                      <p:oleObj name="Graph" r:id="rId9" imgW="6788458" imgH="2335684" progId="Origin50.Graph">
                         <p:embed/>
                         <p:pic>
                           <p:nvPicPr>
@@ -12446,7 +12446,7 @@
                             <p:nvPr/>
                           </p:nvPicPr>
                           <p:blipFill>
-                            <a:blip r:embed="rId8"/>
+                            <a:blip r:embed="rId10"/>
                             <a:stretch>
                               <a:fillRect/>
                             </a:stretch>
@@ -12469,8 +12469,8 @@
             </p:graphicFrame>
           </mc:Fallback>
         </mc:AlternateContent>
-        <mc:AlternateContent xmlns:mc="http://schemas.openxmlformats.org/markup-compatibility/2006">
-          <mc:Choice xmlns:a14="http://schemas.microsoft.com/office/drawing/2010/main" Requires="a14">
+        <mc:AlternateContent xmlns:mc="http://schemas.openxmlformats.org/markup-compatibility/2006" xmlns:a14="http://schemas.microsoft.com/office/drawing/2010/main">
+          <mc:Choice Requires="a14">
             <p:sp>
               <p:nvSpPr>
                 <p:cNvPr id="7" name="TextBox 6">
@@ -12730,7 +12730,7 @@
               </p:txBody>
             </p:sp>
           </mc:Choice>
-          <mc:Fallback>
+          <mc:Fallback xmlns="">
             <p:sp>
               <p:nvSpPr>
                 <p:cNvPr id="7" name="TextBox 6">
@@ -12754,7 +12754,7 @@
                   <a:avLst/>
                 </a:prstGeom>
                 <a:blipFill>
-                  <a:blip r:embed="rId9"/>
+                  <a:blip r:embed="rId11"/>
                   <a:stretch>
                     <a:fillRect/>
                   </a:stretch>
@@ -12775,8 +12775,8 @@
             </p:sp>
           </mc:Fallback>
         </mc:AlternateContent>
-        <mc:AlternateContent xmlns:mc="http://schemas.openxmlformats.org/markup-compatibility/2006">
-          <mc:Choice xmlns:a14="http://schemas.microsoft.com/office/drawing/2010/main" Requires="a14">
+        <mc:AlternateContent xmlns:mc="http://schemas.openxmlformats.org/markup-compatibility/2006" xmlns:a14="http://schemas.microsoft.com/office/drawing/2010/main">
+          <mc:Choice Requires="a14">
             <p:sp>
               <p:nvSpPr>
                 <p:cNvPr id="11" name="TextBox 10">
@@ -13036,7 +13036,7 @@
               </p:txBody>
             </p:sp>
           </mc:Choice>
-          <mc:Fallback>
+          <mc:Fallback xmlns="">
             <p:sp>
               <p:nvSpPr>
                 <p:cNvPr id="11" name="TextBox 10">
@@ -13060,7 +13060,7 @@
                   <a:avLst/>
                 </a:prstGeom>
                 <a:blipFill>
-                  <a:blip r:embed="rId10"/>
+                  <a:blip r:embed="rId12"/>
                   <a:stretch>
                     <a:fillRect/>
                   </a:stretch>
@@ -13570,7 +13570,7 @@
           <p:nvPr/>
         </p:nvPicPr>
         <p:blipFill>
-          <a:blip r:embed="rId11"/>
+          <a:blip r:embed="rId13"/>
           <a:stretch>
             <a:fillRect/>
           </a:stretch>
@@ -14042,330 +14042,288 @@
           </a:graphicData>
         </a:graphic>
       </p:graphicFrame>
-      <p:grpSp>
-        <p:nvGrpSpPr>
-          <p:cNvPr id="12" name="그룹 11">
+      <p:sp>
+        <p:nvSpPr>
+          <p:cNvPr id="4" name="TextBox 3">
             <a:extLst>
               <a:ext uri="{FF2B5EF4-FFF2-40B4-BE49-F238E27FC236}">
-                <a16:creationId xmlns:a16="http://schemas.microsoft.com/office/drawing/2014/main" id="{B2CD97D1-712E-C537-F06E-B436FE4CC01C}"/>
+                <a16:creationId xmlns:a16="http://schemas.microsoft.com/office/drawing/2014/main" id="{66E802A9-74FD-7888-C9ED-71EE57D06572}"/>
               </a:ext>
             </a:extLst>
           </p:cNvPr>
-          <p:cNvGrpSpPr/>
+          <p:cNvSpPr txBox="1"/>
           <p:nvPr/>
-        </p:nvGrpSpPr>
-        <p:grpSpPr>
+        </p:nvSpPr>
+        <p:spPr>
           <a:xfrm>
-            <a:off x="538962" y="1954523"/>
-            <a:ext cx="2706382" cy="2235685"/>
-            <a:chOff x="538962" y="1954523"/>
-            <a:chExt cx="2706382" cy="2235685"/>
+            <a:off x="684634" y="2817178"/>
+            <a:ext cx="360492" cy="215444"/>
           </a:xfrm>
-        </p:grpSpPr>
-        <p:graphicFrame>
-          <p:nvGraphicFramePr>
-            <p:cNvPr id="11" name="개체 10">
-              <a:extLst>
-                <a:ext uri="{FF2B5EF4-FFF2-40B4-BE49-F238E27FC236}">
-                  <a16:creationId xmlns:a16="http://schemas.microsoft.com/office/drawing/2014/main" id="{9B5A1099-6041-1C01-F4D0-017C79986A80}"/>
-                </a:ext>
-              </a:extLst>
-            </p:cNvPr>
-            <p:cNvGraphicFramePr>
-              <a:graphicFrameLocks noChangeAspect="1"/>
-            </p:cNvGraphicFramePr>
-            <p:nvPr>
-              <p:extLst>
-                <p:ext uri="{D42A27DB-BD31-4B8C-83A1-F6EECF244321}">
-                  <p14:modId xmlns:p14="http://schemas.microsoft.com/office/powerpoint/2010/main" val="805515646"/>
-                </p:ext>
-              </p:extLst>
-            </p:nvPr>
-          </p:nvGraphicFramePr>
-          <p:xfrm>
-            <a:off x="538962" y="2935446"/>
-            <a:ext cx="1546698" cy="1092378"/>
-          </p:xfrm>
-          <a:graphic>
-            <a:graphicData uri="http://schemas.openxmlformats.org/presentationml/2006/ole">
-              <mc:AlternateContent xmlns:mc="http://schemas.openxmlformats.org/markup-compatibility/2006">
-                <mc:Choice xmlns:v="urn:schemas-microsoft-com:vml" Requires="v">
-                  <p:oleObj name="Graph" r:id="rId3" imgW="6841724" imgH="4833106" progId="Origin50.Graph">
-                    <p:embed/>
-                  </p:oleObj>
-                </mc:Choice>
-                <mc:Fallback>
-                  <p:oleObj name="Graph" r:id="rId3" imgW="6841724" imgH="4833106" progId="Origin50.Graph">
-                    <p:embed/>
-                    <p:pic>
-                      <p:nvPicPr>
-                        <p:cNvPr id="0" name=""/>
-                        <p:cNvPicPr/>
-                        <p:nvPr/>
-                      </p:nvPicPr>
-                      <p:blipFill>
-                        <a:blip r:embed="rId4"/>
-                        <a:stretch>
-                          <a:fillRect/>
-                        </a:stretch>
-                      </p:blipFill>
-                      <p:spPr>
-                        <a:xfrm>
-                          <a:off x="538962" y="2935446"/>
-                          <a:ext cx="1546698" cy="1092378"/>
-                        </a:xfrm>
-                        <a:prstGeom prst="rect">
-                          <a:avLst/>
-                        </a:prstGeom>
-                      </p:spPr>
-                    </p:pic>
-                  </p:oleObj>
-                </mc:Fallback>
-              </mc:AlternateContent>
-            </a:graphicData>
-          </a:graphic>
-        </p:graphicFrame>
-        <p:grpSp>
-          <p:nvGrpSpPr>
-            <p:cNvPr id="10" name="그룹 9">
-              <a:extLst>
-                <a:ext uri="{FF2B5EF4-FFF2-40B4-BE49-F238E27FC236}">
-                  <a16:creationId xmlns:a16="http://schemas.microsoft.com/office/drawing/2014/main" id="{FD4B5EC7-29B2-EE2A-A3C3-FBE0C7F9C4E4}"/>
-                </a:ext>
-              </a:extLst>
-            </p:cNvPr>
-            <p:cNvGrpSpPr/>
-            <p:nvPr/>
-          </p:nvGrpSpPr>
-          <p:grpSpPr>
-            <a:xfrm>
-              <a:off x="684634" y="1954523"/>
-              <a:ext cx="2560710" cy="2235685"/>
-              <a:chOff x="684634" y="1954523"/>
-              <a:chExt cx="2560710" cy="2235685"/>
-            </a:xfrm>
-          </p:grpSpPr>
-          <p:sp>
-            <p:nvSpPr>
-              <p:cNvPr id="4" name="TextBox 3">
-                <a:extLst>
-                  <a:ext uri="{FF2B5EF4-FFF2-40B4-BE49-F238E27FC236}">
-                    <a16:creationId xmlns:a16="http://schemas.microsoft.com/office/drawing/2014/main" id="{66E802A9-74FD-7888-C9ED-71EE57D06572}"/>
-                  </a:ext>
-                </a:extLst>
-              </p:cNvPr>
-              <p:cNvSpPr txBox="1"/>
-              <p:nvPr/>
-            </p:nvSpPr>
-            <p:spPr>
-              <a:xfrm>
-                <a:off x="684634" y="2817178"/>
-                <a:ext cx="360492" cy="215444"/>
-              </a:xfrm>
-              <a:prstGeom prst="rect">
-                <a:avLst/>
-              </a:prstGeom>
-              <a:noFill/>
-            </p:spPr>
-            <p:txBody>
-              <a:bodyPr wrap="square" rtlCol="0">
-                <a:spAutoFit/>
-              </a:bodyPr>
-              <a:lstStyle/>
-              <a:p>
-                <a:r>
-                  <a:rPr lang="en-US" altLang="ko-KR" sz="800" b="1" dirty="0">
-                    <a:latin typeface="Arial" panose="020B0604020202020204" pitchFamily="34" charset="0"/>
-                    <a:cs typeface="Arial" panose="020B0604020202020204" pitchFamily="34" charset="0"/>
-                  </a:rPr>
-                  <a:t>(b)</a:t>
-                </a:r>
-                <a:endParaRPr lang="ko-KR" altLang="en-US" sz="800" b="1" dirty="0">
-                  <a:latin typeface="Arial" panose="020B0604020202020204" pitchFamily="34" charset="0"/>
-                  <a:cs typeface="Arial" panose="020B0604020202020204" pitchFamily="34" charset="0"/>
-                </a:endParaRPr>
-              </a:p>
-            </p:txBody>
-          </p:sp>
-          <p:graphicFrame>
-            <p:nvGraphicFramePr>
-              <p:cNvPr id="2" name="개체 1">
-                <a:extLst>
-                  <a:ext uri="{FF2B5EF4-FFF2-40B4-BE49-F238E27FC236}">
-                    <a16:creationId xmlns:a16="http://schemas.microsoft.com/office/drawing/2014/main" id="{1AC33133-8D65-1B94-57AA-17E0ABA7F4BD}"/>
-                  </a:ext>
-                </a:extLst>
-              </p:cNvPr>
-              <p:cNvGraphicFramePr>
-                <a:graphicFrameLocks noChangeAspect="1"/>
-              </p:cNvGraphicFramePr>
-              <p:nvPr>
-                <p:extLst>
-                  <p:ext uri="{D42A27DB-BD31-4B8C-83A1-F6EECF244321}">
-                    <p14:modId xmlns:p14="http://schemas.microsoft.com/office/powerpoint/2010/main" val="794590062"/>
-                  </p:ext>
-                </p:extLst>
-              </p:nvPr>
-            </p:nvGraphicFramePr>
-            <p:xfrm>
-              <a:off x="1754707" y="2880691"/>
-              <a:ext cx="1490637" cy="1309517"/>
-            </p:xfrm>
-            <a:graphic>
-              <a:graphicData uri="http://schemas.openxmlformats.org/presentationml/2006/ole">
-                <mc:AlternateContent xmlns:mc="http://schemas.openxmlformats.org/markup-compatibility/2006">
-                  <mc:Choice xmlns:v="urn:schemas-microsoft-com:vml" Requires="v">
-                    <p:oleObj name="Graph" r:id="rId5" imgW="4722409" imgH="2488474" progId="Origin50.Graph">
-                      <p:embed/>
-                    </p:oleObj>
-                  </mc:Choice>
-                  <mc:Fallback>
-                    <p:oleObj name="Graph" r:id="rId5" imgW="4722409" imgH="2488474" progId="Origin50.Graph">
-                      <p:embed/>
-                      <p:pic>
-                        <p:nvPicPr>
-                          <p:cNvPr id="0" name=""/>
-                          <p:cNvPicPr/>
-                          <p:nvPr/>
-                        </p:nvPicPr>
-                        <p:blipFill>
-                          <a:blip r:embed="rId6"/>
-                          <a:stretch>
-                            <a:fillRect/>
-                          </a:stretch>
-                        </p:blipFill>
-                        <p:spPr>
-                          <a:xfrm>
-                            <a:off x="1754707" y="2880691"/>
-                            <a:ext cx="1490637" cy="1309517"/>
-                          </a:xfrm>
-                          <a:prstGeom prst="rect">
-                            <a:avLst/>
-                          </a:prstGeom>
-                        </p:spPr>
-                      </p:pic>
-                    </p:oleObj>
-                  </mc:Fallback>
-                </mc:AlternateContent>
-              </a:graphicData>
-            </a:graphic>
-          </p:graphicFrame>
-          <p:sp>
-            <p:nvSpPr>
-              <p:cNvPr id="3" name="TextBox 2">
-                <a:extLst>
-                  <a:ext uri="{FF2B5EF4-FFF2-40B4-BE49-F238E27FC236}">
-                    <a16:creationId xmlns:a16="http://schemas.microsoft.com/office/drawing/2014/main" id="{A581AD86-F09B-F4D0-5449-FA9C0A6D6076}"/>
-                  </a:ext>
-                </a:extLst>
-              </p:cNvPr>
-              <p:cNvSpPr txBox="1"/>
-              <p:nvPr/>
-            </p:nvSpPr>
-            <p:spPr>
-              <a:xfrm>
-                <a:off x="1905414" y="2817178"/>
-                <a:ext cx="360492" cy="215444"/>
-              </a:xfrm>
-              <a:prstGeom prst="rect">
-                <a:avLst/>
-              </a:prstGeom>
-              <a:noFill/>
-            </p:spPr>
-            <p:txBody>
-              <a:bodyPr wrap="square" rtlCol="0">
-                <a:spAutoFit/>
-              </a:bodyPr>
-              <a:lstStyle/>
-              <a:p>
-                <a:r>
-                  <a:rPr lang="en-US" altLang="ko-KR" sz="800" b="1" dirty="0">
-                    <a:latin typeface="Arial" panose="020B0604020202020204" pitchFamily="34" charset="0"/>
-                    <a:cs typeface="Arial" panose="020B0604020202020204" pitchFamily="34" charset="0"/>
-                  </a:rPr>
-                  <a:t>(c)</a:t>
-                </a:r>
-                <a:endParaRPr lang="ko-KR" altLang="en-US" sz="800" b="1" dirty="0">
-                  <a:latin typeface="Arial" panose="020B0604020202020204" pitchFamily="34" charset="0"/>
-                  <a:cs typeface="Arial" panose="020B0604020202020204" pitchFamily="34" charset="0"/>
-                </a:endParaRPr>
-              </a:p>
-            </p:txBody>
-          </p:sp>
-          <p:pic>
-            <p:nvPicPr>
-              <p:cNvPr id="9" name="그림 8">
-                <a:extLst>
-                  <a:ext uri="{FF2B5EF4-FFF2-40B4-BE49-F238E27FC236}">
-                    <a16:creationId xmlns:a16="http://schemas.microsoft.com/office/drawing/2014/main" id="{387C180F-2D19-7ED7-55A5-47A7347772C5}"/>
-                  </a:ext>
-                </a:extLst>
-              </p:cNvPr>
-              <p:cNvPicPr>
-                <a:picLocks noChangeAspect="1"/>
-              </p:cNvPicPr>
-              <p:nvPr/>
-            </p:nvPicPr>
-            <p:blipFill>
-              <a:blip r:embed="rId7"/>
-              <a:stretch>
-                <a:fillRect/>
-              </a:stretch>
-            </p:blipFill>
-            <p:spPr>
-              <a:xfrm>
-                <a:off x="696036" y="2037271"/>
-                <a:ext cx="2388358" cy="839464"/>
-              </a:xfrm>
-              <a:prstGeom prst="rect">
-                <a:avLst/>
-              </a:prstGeom>
-            </p:spPr>
-          </p:pic>
-          <p:sp>
-            <p:nvSpPr>
-              <p:cNvPr id="5" name="TextBox 4">
-                <a:extLst>
-                  <a:ext uri="{FF2B5EF4-FFF2-40B4-BE49-F238E27FC236}">
-                    <a16:creationId xmlns:a16="http://schemas.microsoft.com/office/drawing/2014/main" id="{1CB1AD94-6D16-AB48-D166-299515E182A9}"/>
-                  </a:ext>
-                </a:extLst>
-              </p:cNvPr>
-              <p:cNvSpPr txBox="1"/>
-              <p:nvPr/>
-            </p:nvSpPr>
-            <p:spPr>
-              <a:xfrm>
-                <a:off x="684634" y="1954523"/>
-                <a:ext cx="360492" cy="215444"/>
-              </a:xfrm>
-              <a:prstGeom prst="rect">
-                <a:avLst/>
-              </a:prstGeom>
-              <a:noFill/>
-            </p:spPr>
-            <p:txBody>
-              <a:bodyPr wrap="square" rtlCol="0">
-                <a:spAutoFit/>
-              </a:bodyPr>
-              <a:lstStyle/>
-              <a:p>
-                <a:r>
-                  <a:rPr lang="en-US" altLang="ko-KR" sz="800" b="1" dirty="0">
-                    <a:latin typeface="Arial" panose="020B0604020202020204" pitchFamily="34" charset="0"/>
-                    <a:cs typeface="Arial" panose="020B0604020202020204" pitchFamily="34" charset="0"/>
-                  </a:rPr>
-                  <a:t>(a)</a:t>
-                </a:r>
-                <a:endParaRPr lang="ko-KR" altLang="en-US" sz="800" b="1" dirty="0">
-                  <a:latin typeface="Arial" panose="020B0604020202020204" pitchFamily="34" charset="0"/>
-                  <a:cs typeface="Arial" panose="020B0604020202020204" pitchFamily="34" charset="0"/>
-                </a:endParaRPr>
-              </a:p>
-            </p:txBody>
-          </p:sp>
-        </p:grpSp>
-      </p:grpSp>
+          <a:prstGeom prst="rect">
+            <a:avLst/>
+          </a:prstGeom>
+          <a:noFill/>
+        </p:spPr>
+        <p:txBody>
+          <a:bodyPr wrap="square" rtlCol="0">
+            <a:spAutoFit/>
+          </a:bodyPr>
+          <a:lstStyle/>
+          <a:p>
+            <a:r>
+              <a:rPr lang="en-US" altLang="ko-KR" sz="800" b="1" dirty="0">
+                <a:latin typeface="Arial" panose="020B0604020202020204" pitchFamily="34" charset="0"/>
+                <a:cs typeface="Arial" panose="020B0604020202020204" pitchFamily="34" charset="0"/>
+              </a:rPr>
+              <a:t>(b)</a:t>
+            </a:r>
+            <a:endParaRPr lang="ko-KR" altLang="en-US" sz="800" b="1" dirty="0">
+              <a:latin typeface="Arial" panose="020B0604020202020204" pitchFamily="34" charset="0"/>
+              <a:cs typeface="Arial" panose="020B0604020202020204" pitchFamily="34" charset="0"/>
+            </a:endParaRPr>
+          </a:p>
+        </p:txBody>
+      </p:sp>
+      <p:sp>
+        <p:nvSpPr>
+          <p:cNvPr id="3" name="TextBox 2">
+            <a:extLst>
+              <a:ext uri="{FF2B5EF4-FFF2-40B4-BE49-F238E27FC236}">
+                <a16:creationId xmlns:a16="http://schemas.microsoft.com/office/drawing/2014/main" id="{A581AD86-F09B-F4D0-5449-FA9C0A6D6076}"/>
+              </a:ext>
+            </a:extLst>
+          </p:cNvPr>
+          <p:cNvSpPr txBox="1"/>
+          <p:nvPr/>
+        </p:nvSpPr>
+        <p:spPr>
+          <a:xfrm>
+            <a:off x="1905414" y="2817178"/>
+            <a:ext cx="360492" cy="215444"/>
+          </a:xfrm>
+          <a:prstGeom prst="rect">
+            <a:avLst/>
+          </a:prstGeom>
+          <a:noFill/>
+        </p:spPr>
+        <p:txBody>
+          <a:bodyPr wrap="square" rtlCol="0">
+            <a:spAutoFit/>
+          </a:bodyPr>
+          <a:lstStyle/>
+          <a:p>
+            <a:r>
+              <a:rPr lang="en-US" altLang="ko-KR" sz="800" b="1" dirty="0">
+                <a:latin typeface="Arial" panose="020B0604020202020204" pitchFamily="34" charset="0"/>
+                <a:cs typeface="Arial" panose="020B0604020202020204" pitchFamily="34" charset="0"/>
+              </a:rPr>
+              <a:t>(c)</a:t>
+            </a:r>
+            <a:endParaRPr lang="ko-KR" altLang="en-US" sz="800" b="1" dirty="0">
+              <a:latin typeface="Arial" panose="020B0604020202020204" pitchFamily="34" charset="0"/>
+              <a:cs typeface="Arial" panose="020B0604020202020204" pitchFamily="34" charset="0"/>
+            </a:endParaRPr>
+          </a:p>
+        </p:txBody>
+      </p:sp>
+      <p:pic>
+        <p:nvPicPr>
+          <p:cNvPr id="9" name="그림 8">
+            <a:extLst>
+              <a:ext uri="{FF2B5EF4-FFF2-40B4-BE49-F238E27FC236}">
+                <a16:creationId xmlns:a16="http://schemas.microsoft.com/office/drawing/2014/main" id="{387C180F-2D19-7ED7-55A5-47A7347772C5}"/>
+              </a:ext>
+            </a:extLst>
+          </p:cNvPr>
+          <p:cNvPicPr>
+            <a:picLocks noChangeAspect="1"/>
+          </p:cNvPicPr>
+          <p:nvPr/>
+        </p:nvPicPr>
+        <p:blipFill>
+          <a:blip r:embed="rId3"/>
+          <a:stretch>
+            <a:fillRect/>
+          </a:stretch>
+        </p:blipFill>
+        <p:spPr>
+          <a:xfrm>
+            <a:off x="696036" y="2037271"/>
+            <a:ext cx="2388358" cy="839464"/>
+          </a:xfrm>
+          <a:prstGeom prst="rect">
+            <a:avLst/>
+          </a:prstGeom>
+        </p:spPr>
+      </p:pic>
+      <p:sp>
+        <p:nvSpPr>
+          <p:cNvPr id="5" name="TextBox 4">
+            <a:extLst>
+              <a:ext uri="{FF2B5EF4-FFF2-40B4-BE49-F238E27FC236}">
+                <a16:creationId xmlns:a16="http://schemas.microsoft.com/office/drawing/2014/main" id="{1CB1AD94-6D16-AB48-D166-299515E182A9}"/>
+              </a:ext>
+            </a:extLst>
+          </p:cNvPr>
+          <p:cNvSpPr txBox="1"/>
+          <p:nvPr/>
+        </p:nvSpPr>
+        <p:spPr>
+          <a:xfrm>
+            <a:off x="684634" y="1954523"/>
+            <a:ext cx="360492" cy="215444"/>
+          </a:xfrm>
+          <a:prstGeom prst="rect">
+            <a:avLst/>
+          </a:prstGeom>
+          <a:noFill/>
+        </p:spPr>
+        <p:txBody>
+          <a:bodyPr wrap="square" rtlCol="0">
+            <a:spAutoFit/>
+          </a:bodyPr>
+          <a:lstStyle/>
+          <a:p>
+            <a:r>
+              <a:rPr lang="en-US" altLang="ko-KR" sz="800" b="1" dirty="0">
+                <a:latin typeface="Arial" panose="020B0604020202020204" pitchFamily="34" charset="0"/>
+                <a:cs typeface="Arial" panose="020B0604020202020204" pitchFamily="34" charset="0"/>
+              </a:rPr>
+              <a:t>(a)</a:t>
+            </a:r>
+            <a:endParaRPr lang="ko-KR" altLang="en-US" sz="800" b="1" dirty="0">
+              <a:latin typeface="Arial" panose="020B0604020202020204" pitchFamily="34" charset="0"/>
+              <a:cs typeface="Arial" panose="020B0604020202020204" pitchFamily="34" charset="0"/>
+            </a:endParaRPr>
+          </a:p>
+        </p:txBody>
+      </p:sp>
+      <p:graphicFrame>
+        <p:nvGraphicFramePr>
+          <p:cNvPr id="6" name="개체 5">
+            <a:extLst>
+              <a:ext uri="{FF2B5EF4-FFF2-40B4-BE49-F238E27FC236}">
+                <a16:creationId xmlns:a16="http://schemas.microsoft.com/office/drawing/2014/main" id="{04824797-986D-386C-6AF1-4BB0E95210D1}"/>
+              </a:ext>
+            </a:extLst>
+          </p:cNvPr>
+          <p:cNvGraphicFramePr>
+            <a:graphicFrameLocks noChangeAspect="1"/>
+          </p:cNvGraphicFramePr>
+          <p:nvPr>
+            <p:extLst>
+              <p:ext uri="{D42A27DB-BD31-4B8C-83A1-F6EECF244321}">
+                <p14:modId xmlns:p14="http://schemas.microsoft.com/office/powerpoint/2010/main" val="1786175544"/>
+              </p:ext>
+            </p:extLst>
+          </p:nvPr>
+        </p:nvGraphicFramePr>
+        <p:xfrm>
+          <a:off x="621911" y="2959483"/>
+          <a:ext cx="1368826" cy="966753"/>
+        </p:xfrm>
+        <a:graphic>
+          <a:graphicData uri="http://schemas.openxmlformats.org/presentationml/2006/ole">
+            <mc:AlternateContent xmlns:mc="http://schemas.openxmlformats.org/markup-compatibility/2006">
+              <mc:Choice xmlns:v="urn:schemas-microsoft-com:vml" Requires="v">
+                <p:oleObj name="Graph" r:id="rId4" imgW="6841724" imgH="4833106" progId="Origin50.Graph">
+                  <p:embed/>
+                </p:oleObj>
+              </mc:Choice>
+              <mc:Fallback>
+                <p:oleObj name="Graph" r:id="rId4" imgW="6841724" imgH="4833106" progId="Origin50.Graph">
+                  <p:embed/>
+                  <p:pic>
+                    <p:nvPicPr>
+                      <p:cNvPr id="0" name=""/>
+                      <p:cNvPicPr/>
+                      <p:nvPr/>
+                    </p:nvPicPr>
+                    <p:blipFill>
+                      <a:blip r:embed="rId5"/>
+                      <a:stretch>
+                        <a:fillRect/>
+                      </a:stretch>
+                    </p:blipFill>
+                    <p:spPr>
+                      <a:xfrm>
+                        <a:off x="621911" y="2959483"/>
+                        <a:ext cx="1368826" cy="966753"/>
+                      </a:xfrm>
+                      <a:prstGeom prst="rect">
+                        <a:avLst/>
+                      </a:prstGeom>
+                    </p:spPr>
+                  </p:pic>
+                </p:oleObj>
+              </mc:Fallback>
+            </mc:AlternateContent>
+          </a:graphicData>
+        </a:graphic>
+      </p:graphicFrame>
+      <p:graphicFrame>
+        <p:nvGraphicFramePr>
+          <p:cNvPr id="7" name="개체 6">
+            <a:extLst>
+              <a:ext uri="{FF2B5EF4-FFF2-40B4-BE49-F238E27FC236}">
+                <a16:creationId xmlns:a16="http://schemas.microsoft.com/office/drawing/2014/main" id="{BB27341B-A4C5-6C0F-F5B3-A72DEBEA6A31}"/>
+              </a:ext>
+            </a:extLst>
+          </p:cNvPr>
+          <p:cNvGraphicFramePr>
+            <a:graphicFrameLocks noChangeAspect="1"/>
+          </p:cNvGraphicFramePr>
+          <p:nvPr>
+            <p:extLst>
+              <p:ext uri="{D42A27DB-BD31-4B8C-83A1-F6EECF244321}">
+                <p14:modId xmlns:p14="http://schemas.microsoft.com/office/powerpoint/2010/main" val="2773690956"/>
+              </p:ext>
+            </p:extLst>
+          </p:nvPr>
+        </p:nvGraphicFramePr>
+        <p:xfrm>
+          <a:off x="1869426" y="2959482"/>
+          <a:ext cx="1368826" cy="966753"/>
+        </p:xfrm>
+        <a:graphic>
+          <a:graphicData uri="http://schemas.openxmlformats.org/presentationml/2006/ole">
+            <mc:AlternateContent xmlns:mc="http://schemas.openxmlformats.org/markup-compatibility/2006">
+              <mc:Choice xmlns:v="urn:schemas-microsoft-com:vml" Requires="v">
+                <p:oleObj name="Graph" r:id="rId6" imgW="6841724" imgH="4833106" progId="Origin50.Graph">
+                  <p:embed/>
+                </p:oleObj>
+              </mc:Choice>
+              <mc:Fallback>
+                <p:oleObj name="Graph" r:id="rId6" imgW="6841724" imgH="4833106" progId="Origin50.Graph">
+                  <p:embed/>
+                  <p:pic>
+                    <p:nvPicPr>
+                      <p:cNvPr id="0" name=""/>
+                      <p:cNvPicPr/>
+                      <p:nvPr/>
+                    </p:nvPicPr>
+                    <p:blipFill>
+                      <a:blip r:embed="rId7"/>
+                      <a:stretch>
+                        <a:fillRect/>
+                      </a:stretch>
+                    </p:blipFill>
+                    <p:spPr>
+                      <a:xfrm>
+                        <a:off x="1869426" y="2959482"/>
+                        <a:ext cx="1368826" cy="966753"/>
+                      </a:xfrm>
+                      <a:prstGeom prst="rect">
+                        <a:avLst/>
+                      </a:prstGeom>
+                    </p:spPr>
+                  </p:pic>
+                </p:oleObj>
+              </mc:Fallback>
+            </mc:AlternateContent>
+          </a:graphicData>
+        </a:graphic>
+      </p:graphicFrame>
     </p:spTree>
     <p:extLst>
       <p:ext uri="{BB962C8B-B14F-4D97-AF65-F5344CB8AC3E}">

</xml_diff>